<commit_message>
Indicative deck: point Data Pack references at handout sections 4.1-4.5
Co-authored-by: Copilot <223556219+Copilot@users.noreply.github.com>
</commit_message>
<xml_diff>
--- a/01_case_study_handouts/case_study_helper_info/99_Indicative-Submission_Deck.pptx
+++ b/01_case_study_handouts/case_study_helper_info/99_Indicative-Submission_Deck.pptx
@@ -2896,7 +2896,7 @@
                 <a:ea typeface="Calibri" pitchFamily="34" charset="-122"/>
                 <a:cs typeface="Calibri" pitchFamily="34" charset="-120"/>
               </a:rPr>
-              <a:t>[Import duty: 00% · excise: €0.00 per bottle · consumer tax: 00% — from Data Pack 3.3]</a:t>
+              <a:t>[Import duty: 00% · excise: €0.00 per bottle · consumer tax: 00% — from Data Pack 4.3]</a:t>
             </a:r>
             <a:endParaRPr lang="en-US" sz="1500" dirty="0"/>
           </a:p>
@@ -4751,7 +4751,7 @@
                 <a:ea typeface="Calibri" pitchFamily="34" charset="-122"/>
                 <a:cs typeface="Calibri" pitchFamily="34" charset="-120"/>
               </a:rPr>
-              <a:t>Prove the economics are built, not asserted. Every row traces to Data Pack 3.1–3.5.</a:t>
+              <a:t>Prove the economics are built, not asserted. Every row traces to Data Pack 4.1–4.5.</a:t>
             </a:r>
             <a:endParaRPr lang="en-US" sz="950" dirty="0"/>
           </a:p>

</xml_diff>